<commit_message>
docs: finalize SIH Idea Submission PPTX with student name and PS details
</commit_message>
<xml_diff>
--- a/SIH_Idea_Submission.pptx
+++ b/SIH_Idea_Submission.pptx
@@ -3197,7 +3197,7 @@
                 </a:solidFill>
                 <a:latin typeface="Arial"/>
               </a:rPr>
-              <a:t>SIH1608 (Eco-Loop Building Agents)</a:t>
+              <a:t>1</a:t>
             </a:r>
           </a:p>
           <a:p>
@@ -3222,7 +3222,7 @@
                 </a:solidFill>
                 <a:latin typeface="Arial"/>
               </a:rPr>
-              <a:t>Autonomous building energy management with open-source LLM &amp; MCP</a:t>
+              <a:t>AI-Powered Autonomous Smart Building Optimization Challenge</a:t>
             </a:r>
           </a:p>
           <a:p>
@@ -3297,7 +3297,7 @@
                 </a:solidFill>
                 <a:latin typeface="Arial"/>
               </a:rPr>
-              <a:t>[Your Registered Name]  &lt;!-- Double-click to Edit --&gt;</a:t>
+              <a:t>Sagar Raj</a:t>
             </a:r>
           </a:p>
           <a:p>
@@ -3322,7 +3322,7 @@
                 </a:solidFill>
                 <a:latin typeface="Arial"/>
               </a:rPr>
-              <a:t>[Your Registered ID]  &lt;!-- Double-click to Edit --&gt;</a:t>
+              <a:t>20524983</a:t>
             </a:r>
           </a:p>
         </p:txBody>

</xml_diff>